<commit_message>
Translate presentation to English
</commit_message>
<xml_diff>
--- a/RL_GridWorld_Presentation.pptx
+++ b/RL_GridWorld_Presentation.pptx
@@ -140,7 +140,7 @@
                 </a:solidFill>
                 <a:latin typeface="Arial"/>
               </a:rPr>
-              <a:t>Belohnung pro Episode</a:t>
+              <a:t>Reward per Episode</a:t>
             </a:r>
           </a:p>
         </c:rich>
@@ -2881,7 +2881,7 @@
                   <a:srgbClr val="14B8A6"/>
                 </a:solidFill>
               </a:rPr>
-              <a:t>Grid World Navigation mit Q-Learning</a:t>
+              <a:t>Grid World Navigation with Q-Learning</a:t>
             </a:r>
             <a:endParaRPr lang="en-US" sz="1800" dirty="0"/>
           </a:p>
@@ -3071,7 +3071,7 @@
                   <a:srgbClr val="FFFFFF"/>
                 </a:solidFill>
               </a:rPr>
-              <a:t>Was ist Reinforcement Learning?</a:t>
+              <a:t>What is Reinforcement Learning?</a:t>
             </a:r>
             <a:endParaRPr lang="en-US" sz="2200" dirty="0"/>
           </a:p>
@@ -3139,7 +3139,7 @@
                   <a:srgbClr val="0D9488"/>
                 </a:solidFill>
               </a:rPr>
-              <a:t>Die Idee</a:t>
+              <a:t>The Idea</a:t>
             </a:r>
             <a:endParaRPr lang="en-US" sz="1500" dirty="0"/>
           </a:p>
@@ -3175,7 +3175,7 @@
                   <a:srgbClr val="1E293B"/>
                 </a:solidFill>
               </a:rPr>
-              <a:t>Ein Agent interagiert mit einer Umgebung.</a:t>
+              <a:t>An agent interacts with an environment.</a:t>
             </a:r>
             <a:endParaRPr lang="en-US" sz="1300" dirty="0"/>
           </a:p>
@@ -3203,7 +3203,7 @@
                   <a:srgbClr val="1E293B"/>
                 </a:solidFill>
               </a:rPr>
-              <a:t>Er probiert Aktionen aus, bekommt Belohnungen oder Strafen — und lernt mit der Zeit, immer besser zu werden.</a:t>
+              <a:t>It tries actions, receives rewards or penalties — and learns over time to get better and better.</a:t>
             </a:r>
             <a:endParaRPr lang="en-US" sz="1300" dirty="0"/>
           </a:p>
@@ -3231,7 +3231,7 @@
                   <a:srgbClr val="1E293B"/>
                 </a:solidFill>
               </a:rPr>
-              <a:t>Kein gelabeltes Daten. Kein Lehrer. Nur: ausprobieren → Feedback → verbessern.</a:t>
+              <a:t>No labeled data. No teacher. Just: try → get feedback → improve.</a:t>
             </a:r>
             <a:endParaRPr lang="en-US" sz="1300" dirty="0"/>
           </a:p>
@@ -3299,7 +3299,7 @@
                   <a:srgbClr val="0D9488"/>
                 </a:solidFill>
               </a:rPr>
-              <a:t>Die 5 Kernbegriffe</a:t>
+              <a:t>The 5 Key Concepts</a:t>
             </a:r>
             <a:endParaRPr lang="en-US" sz="1500" dirty="0"/>
           </a:p>
@@ -3371,7 +3371,7 @@
                   <a:srgbClr val="64748B"/>
                 </a:solidFill>
               </a:rPr>
-              <a:t>Der Lernende — trifft Entscheidungen</a:t>
+              <a:t>The learner — makes decisions</a:t>
             </a:r>
             <a:endParaRPr lang="en-US" sz="1100" dirty="0"/>
           </a:p>
@@ -3407,7 +3407,7 @@
                   <a:srgbClr val="1E293B"/>
                 </a:solidFill>
               </a:rPr>
-              <a:t>🌍  Umgebung</a:t>
+              <a:t>🌍  Environment</a:t>
             </a:r>
             <a:endParaRPr lang="en-US" sz="1200" dirty="0"/>
           </a:p>
@@ -3443,7 +3443,7 @@
                   <a:srgbClr val="64748B"/>
                 </a:solidFill>
               </a:rPr>
-              <a:t>Das System, in dem er agiert</a:t>
+              <a:t>The system the agent operates in</a:t>
             </a:r>
             <a:endParaRPr lang="en-US" sz="1100" dirty="0"/>
           </a:p>
@@ -3479,7 +3479,7 @@
                   <a:srgbClr val="1E293B"/>
                 </a:solidFill>
               </a:rPr>
-              <a:t>📍  Zustand (State)</a:t>
+              <a:t>📍  State</a:t>
             </a:r>
             <a:endParaRPr lang="en-US" sz="1200" dirty="0"/>
           </a:p>
@@ -3515,7 +3515,7 @@
                   <a:srgbClr val="64748B"/>
                 </a:solidFill>
               </a:rPr>
-              <a:t>Wo befindet sich der Agent gerade?</a:t>
+              <a:t>Where is the agent right now?</a:t>
             </a:r>
             <a:endParaRPr lang="en-US" sz="1100" dirty="0"/>
           </a:p>
@@ -3551,7 +3551,7 @@
                   <a:srgbClr val="1E293B"/>
                 </a:solidFill>
               </a:rPr>
-              <a:t>🎮  Aktion</a:t>
+              <a:t>🎮  Action</a:t>
             </a:r>
             <a:endParaRPr lang="en-US" sz="1200" dirty="0"/>
           </a:p>
@@ -3587,7 +3587,7 @@
                   <a:srgbClr val="64748B"/>
                 </a:solidFill>
               </a:rPr>
-              <a:t>Was tut er als nächstes?</a:t>
+              <a:t>What does it do next?</a:t>
             </a:r>
             <a:endParaRPr lang="en-US" sz="1100" dirty="0"/>
           </a:p>
@@ -3623,7 +3623,7 @@
                   <a:srgbClr val="1E293B"/>
                 </a:solidFill>
               </a:rPr>
-              <a:t>🏆  Belohnung</a:t>
+              <a:t>🏆  Reward</a:t>
             </a:r>
             <a:endParaRPr lang="en-US" sz="1200" dirty="0"/>
           </a:p>
@@ -3659,7 +3659,7 @@
                   <a:srgbClr val="64748B"/>
                 </a:solidFill>
               </a:rPr>
-              <a:t>Wie gut war die Entscheidung?</a:t>
+              <a:t>How good was the decision?</a:t>
             </a:r>
             <a:endParaRPr lang="en-US" sz="1100" dirty="0"/>
           </a:p>
@@ -3720,7 +3720,7 @@
                   <a:srgbClr val="FFFFFF"/>
                 </a:solidFill>
               </a:rPr>
-              <a:t>Folie 1 / 7</a:t>
+              <a:t>Slide 1 / 7</a:t>
             </a:r>
             <a:endParaRPr lang="en-US" sz="1000" dirty="0"/>
           </a:p>
@@ -3813,7 +3813,7 @@
                   <a:srgbClr val="FFFFFF"/>
                 </a:solidFill>
               </a:rPr>
-              <a:t>Das Problem: Grid World</a:t>
+              <a:t>The Problem: Grid World</a:t>
             </a:r>
             <a:endParaRPr lang="en-US" sz="2200" dirty="0"/>
           </a:p>
@@ -6453,7 +6453,7 @@
                   <a:srgbClr val="0D9488"/>
                 </a:solidFill>
               </a:rPr>
-              <a:t>Aufgabe des Agenten</a:t>
+              <a:t>Agent's Task</a:t>
             </a:r>
             <a:endParaRPr lang="en-US" sz="1500" dirty="0"/>
           </a:p>
@@ -6552,7 +6552,7 @@
                   <a:srgbClr val="1E293B"/>
                 </a:solidFill>
               </a:rPr>
-              <a:t>(oben links)  →  Ziel (unten rechts)</a:t>
+              <a:t>(top left)  →  Goal (bottom right)</a:t>
             </a:r>
             <a:endParaRPr lang="en-US" sz="1200" dirty="0"/>
           </a:p>
@@ -6651,7 +6651,7 @@
                   <a:srgbClr val="1E293B"/>
                 </a:solidFill>
               </a:rPr>
-              <a:t>Wände = verboten (Strafe: -10)</a:t>
+              <a:t>Walls = forbidden (penalty: -10)</a:t>
             </a:r>
             <a:endParaRPr lang="en-US" sz="1200" dirty="0"/>
           </a:p>
@@ -6750,7 +6750,7 @@
                   <a:srgbClr val="1E293B"/>
                 </a:solidFill>
               </a:rPr>
-              <a:t>kostet -1 Punkt (kürzter Weg!)</a:t>
+              <a:t>costs -1 point (find shortest path!)</a:t>
             </a:r>
             <a:endParaRPr lang="en-US" sz="1200" dirty="0"/>
           </a:p>
@@ -6849,7 +6849,7 @@
                   <a:srgbClr val="1E293B"/>
                 </a:solidFill>
               </a:rPr>
-              <a:t>+50 Punkte Belohnung</a:t>
+              <a:t>+50 points reward</a:t>
             </a:r>
             <a:endParaRPr lang="en-US" sz="1200" dirty="0"/>
           </a:p>
@@ -6948,7 +6948,7 @@
                   <a:srgbClr val="1E293B"/>
                 </a:solidFill>
               </a:rPr>
-              <a:t>um den besten Weg zu lernen</a:t>
+              <a:t>to learn the optimal path</a:t>
             </a:r>
             <a:endParaRPr lang="en-US" sz="1200" dirty="0"/>
           </a:p>
@@ -7131,7 +7131,7 @@
                   <a:srgbClr val="1E293B"/>
                 </a:solidFill>
               </a:rPr>
-              <a:t>Gelernter Pfad</a:t>
+              <a:t>Learned Path</a:t>
             </a:r>
             <a:endParaRPr lang="en-US" sz="900" dirty="0"/>
           </a:p>
@@ -7192,7 +7192,7 @@
                   <a:srgbClr val="1E293B"/>
                 </a:solidFill>
               </a:rPr>
-              <a:t>Wand</a:t>
+              <a:t>Wall</a:t>
             </a:r>
             <a:endParaRPr lang="en-US" sz="900" dirty="0"/>
           </a:p>
@@ -7253,7 +7253,7 @@
                   <a:srgbClr val="FFFFFF"/>
                 </a:solidFill>
               </a:rPr>
-              <a:t>Folie 2 / 7</a:t>
+              <a:t>Slide 2 / 7</a:t>
             </a:r>
             <a:endParaRPr lang="en-US" sz="1000" dirty="0"/>
           </a:p>
@@ -7346,7 +7346,7 @@
                   <a:srgbClr val="FFFFFF"/>
                 </a:solidFill>
               </a:rPr>
-              <a:t>Q-Learning: Wie funktioniert es?</a:t>
+              <a:t>Q-Learning: How Does It Work?</a:t>
             </a:r>
             <a:endParaRPr lang="en-US" sz="2200" dirty="0"/>
           </a:p>
@@ -7414,7 +7414,7 @@
                   <a:srgbClr val="F59E0B"/>
                 </a:solidFill>
               </a:rPr>
-              <a:t>🎮  Analogie:</a:t>
+              <a:t>🎮  Analogy:</a:t>
             </a:r>
             <a:endParaRPr lang="en-US" sz="1300" dirty="0"/>
           </a:p>
@@ -7450,7 +7450,7 @@
                   <a:srgbClr val="FFFFFF"/>
                 </a:solidFill>
               </a:rPr>
-              <a:t>Wie ein Videospiel-Neuling — zuerst random Knöpfe drücken, dann aus Fehlern lernen, irgendwann den Level im Schlaf durchspielen.</a:t>
+              <a:t>Like a video game newbie — first pressing random buttons, then learning from mistakes, eventually playing the level in your sleep.</a:t>
             </a:r>
             <a:endParaRPr lang="en-US" sz="1300" dirty="0"/>
           </a:p>
@@ -7543,7 +7543,7 @@
                   <a:srgbClr val="FFFFFF"/>
                 </a:solidFill>
               </a:rPr>
-              <a:t>1. Beobachten</a:t>
+              <a:t>1. Observe</a:t>
             </a:r>
             <a:endParaRPr lang="en-US" sz="1200" dirty="0"/>
           </a:p>
@@ -7615,7 +7615,7 @@
                   <a:srgbClr val="64748B"/>
                 </a:solidFill>
               </a:rPr>
-              <a:t>Agent sieht seinen</a:t>
+              <a:t>Agent sees its</a:t>
             </a:r>
             <a:endParaRPr lang="en-US" sz="1100" dirty="0"/>
           </a:p>
@@ -7629,7 +7629,7 @@
                   <a:srgbClr val="64748B"/>
                 </a:solidFill>
               </a:rPr>
-              <a:t>aktuellen Zustand</a:t>
+              <a:t>current state</a:t>
             </a:r>
             <a:endParaRPr lang="en-US" sz="1100" dirty="0"/>
           </a:p>
@@ -7747,7 +7747,7 @@
                   <a:srgbClr val="FFFFFF"/>
                 </a:solidFill>
               </a:rPr>
-              <a:t>2. Handeln</a:t>
+              <a:t>2. Act</a:t>
             </a:r>
             <a:endParaRPr lang="en-US" sz="1200" dirty="0"/>
           </a:p>
@@ -7819,7 +7819,7 @@
                   <a:srgbClr val="64748B"/>
                 </a:solidFill>
               </a:rPr>
-              <a:t>Wählt eine Aktion</a:t>
+              <a:t>Picks an action</a:t>
             </a:r>
             <a:endParaRPr lang="en-US" sz="1100" dirty="0"/>
           </a:p>
@@ -8023,7 +8023,7 @@
                   <a:srgbClr val="64748B"/>
                 </a:solidFill>
               </a:rPr>
-              <a:t>Erhält Belohnung</a:t>
+              <a:t>Receives reward</a:t>
             </a:r>
             <a:endParaRPr lang="en-US" sz="1100" dirty="0"/>
           </a:p>
@@ -8037,7 +8037,7 @@
                   <a:srgbClr val="64748B"/>
                 </a:solidFill>
               </a:rPr>
-              <a:t>oder Strafe</a:t>
+              <a:t>or penalty</a:t>
             </a:r>
             <a:endParaRPr lang="en-US" sz="1100" dirty="0"/>
           </a:p>
@@ -8155,7 +8155,7 @@
                   <a:srgbClr val="FFFFFF"/>
                 </a:solidFill>
               </a:rPr>
-              <a:t>4. Lernen</a:t>
+              <a:t>4. Learn</a:t>
             </a:r>
             <a:endParaRPr lang="en-US" sz="1200" dirty="0"/>
           </a:p>
@@ -8227,7 +8227,7 @@
                   <a:srgbClr val="64748B"/>
                 </a:solidFill>
               </a:rPr>
-              <a:t>Aktualisiert die</a:t>
+              <a:t>Updates the</a:t>
             </a:r>
             <a:endParaRPr lang="en-US" sz="1100" dirty="0"/>
           </a:p>
@@ -8241,7 +8241,7 @@
                   <a:srgbClr val="64748B"/>
                 </a:solidFill>
               </a:rPr>
-              <a:t>Q-Tabelle</a:t>
+              <a:t>Q-table</a:t>
             </a:r>
             <a:endParaRPr lang="en-US" sz="1100" dirty="0"/>
           </a:p>
@@ -8409,7 +8409,7 @@
                   <a:srgbClr val="FFFFFF"/>
                 </a:solidFill>
               </a:rPr>
-              <a:t>Folie 3 / 7</a:t>
+              <a:t>Slide 3 / 7</a:t>
             </a:r>
             <a:endParaRPr lang="en-US" sz="1000" dirty="0"/>
           </a:p>
@@ -8502,7 +8502,7 @@
                   <a:srgbClr val="FFFFFF"/>
                 </a:solidFill>
               </a:rPr>
-              <a:t>Schlüssel-Parameter &amp; ε-Greedy Strategie</a:t>
+              <a:t>Key Parameters &amp; ε-Greedy Strategy</a:t>
             </a:r>
             <a:endParaRPr lang="en-US" sz="2200" dirty="0"/>
           </a:p>
@@ -8667,7 +8667,7 @@
                   <a:srgbClr val="14B8A6"/>
                 </a:solidFill>
               </a:rPr>
-              <a:t>Wert</a:t>
+              <a:t>Value</a:t>
             </a:r>
             <a:endParaRPr lang="en-US" sz="1100" dirty="0"/>
           </a:p>
@@ -8703,7 +8703,7 @@
                   <a:srgbClr val="14B8A6"/>
                 </a:solidFill>
               </a:rPr>
-              <a:t>Bedeutung</a:t>
+              <a:t>Meaning</a:t>
             </a:r>
             <a:endParaRPr lang="en-US" sz="1100" dirty="0"/>
           </a:p>
@@ -8864,7 +8864,7 @@
                   <a:srgbClr val="64748B"/>
                 </a:solidFill>
               </a:rPr>
-              <a:t>Lernrate — wie stark neue Info alte überschreibt</a:t>
+              <a:t>Learning rate — how much new info overrides old</a:t>
             </a:r>
             <a:endParaRPr lang="en-US" sz="1100" dirty="0"/>
           </a:p>
@@ -9025,7 +9025,7 @@
                   <a:srgbClr val="64748B"/>
                 </a:solidFill>
               </a:rPr>
-              <a:t>Diskontierung — zukünftige Belohnungen zählen fast gleich viel</a:t>
+              <a:t>Discount factor — future rewards count almost as much as immediate</a:t>
             </a:r>
             <a:endParaRPr lang="en-US" sz="1100" dirty="0"/>
           </a:p>
@@ -9186,7 +9186,7 @@
                   <a:srgbClr val="64748B"/>
                 </a:solidFill>
               </a:rPr>
-              <a:t>Exploration sinkt mit jeder Episode</a:t>
+              <a:t>Exploration decays each episode</a:t>
             </a:r>
             <a:endParaRPr lang="en-US" sz="1100" dirty="0"/>
           </a:p>
@@ -9347,7 +9347,7 @@
                   <a:srgbClr val="64748B"/>
                 </a:solidFill>
               </a:rPr>
-              <a:t>Anzahl der kompletten Durchläufe durchs Labyrinth</a:t>
+              <a:t>Number of complete runs through the maze</a:t>
             </a:r>
             <a:endParaRPr lang="en-US" sz="1100" dirty="0"/>
           </a:p>
@@ -9415,7 +9415,7 @@
                   <a:srgbClr val="0D9488"/>
                 </a:solidFill>
               </a:rPr>
-              <a:t>ε-Greedy Strategie</a:t>
+              <a:t>ε-Greedy Strategy</a:t>
             </a:r>
             <a:endParaRPr lang="en-US" sz="1400" dirty="0"/>
           </a:p>
@@ -9514,7 +9514,7 @@
                   <a:srgbClr val="1E293B"/>
                 </a:solidFill>
               </a:rPr>
-              <a:t>Zufällige Aktion</a:t>
+              <a:t>Random action</a:t>
             </a:r>
             <a:endParaRPr lang="en-US" sz="1000" dirty="0"/>
           </a:p>
@@ -9528,7 +9528,7 @@
                   <a:srgbClr val="1E293B"/>
                 </a:solidFill>
               </a:rPr>
-              <a:t>Agent erkundet unbekannte Felder</a:t>
+              <a:t>Agent explores unknown cells</a:t>
             </a:r>
             <a:endParaRPr lang="en-US" sz="1000" dirty="0"/>
           </a:p>
@@ -9564,7 +9564,7 @@
                   <a:srgbClr val="64748B"/>
                 </a:solidFill>
               </a:rPr>
-              <a:t>mit Wahrsch. ε    vs    (1-ε)</a:t>
+              <a:t>with prob. ε    vs    (1-ε)</a:t>
             </a:r>
             <a:endParaRPr lang="en-US" sz="1000" dirty="0"/>
           </a:p>
@@ -9663,7 +9663,7 @@
                   <a:srgbClr val="1E293B"/>
                 </a:solidFill>
               </a:rPr>
-              <a:t>Beste bekannte Aktion</a:t>
+              <a:t>Best known action</a:t>
             </a:r>
             <a:endParaRPr lang="en-US" sz="1000" dirty="0"/>
           </a:p>
@@ -9677,7 +9677,7 @@
                   <a:srgbClr val="1E293B"/>
                 </a:solidFill>
               </a:rPr>
-              <a:t>Agent nutzt sein Wissen</a:t>
+              <a:t>Agent uses its knowledge</a:t>
             </a:r>
             <a:endParaRPr lang="en-US" sz="1000" dirty="0"/>
           </a:p>
@@ -9738,7 +9738,7 @@
                   <a:srgbClr val="FFFFFF"/>
                 </a:solidFill>
               </a:rPr>
-              <a:t>Folie 4 / 7</a:t>
+              <a:t>Slide 4 / 7</a:t>
             </a:r>
             <a:endParaRPr lang="en-US" sz="1000" dirty="0"/>
           </a:p>
@@ -9831,7 +9831,7 @@
                   <a:srgbClr val="FFFFFF"/>
                 </a:solidFill>
               </a:rPr>
-              <a:t>Implementierung: Code-Überblick</a:t>
+              <a:t>Implementation: Code Overview</a:t>
             </a:r>
             <a:endParaRPr lang="en-US" sz="2200" dirty="0"/>
           </a:p>
@@ -10212,7 +10212,7 @@
                   <a:srgbClr val="0D9488"/>
                 </a:solidFill>
               </a:rPr>
-              <a:t>7 Schritte im Notebook</a:t>
+              <a:t>7 Steps in the Notebook</a:t>
             </a:r>
             <a:endParaRPr lang="en-US" sz="1300" dirty="0"/>
           </a:p>
@@ -10309,7 +10309,7 @@
                   <a:srgbClr val="1E293B"/>
                 </a:solidFill>
               </a:rPr>
-              <a:t>Libraries &amp; Labyrinth</a:t>
+              <a:t>Libraries &amp; Maze</a:t>
             </a:r>
             <a:endParaRPr lang="en-US" sz="1100" dirty="0"/>
           </a:p>
@@ -10406,7 +10406,7 @@
                   <a:srgbClr val="1E293B"/>
                 </a:solidFill>
               </a:rPr>
-              <a:t>RL Parameter &amp; Q-Tabelle</a:t>
+              <a:t>RL Parameters &amp; Q-Table</a:t>
             </a:r>
             <a:endParaRPr lang="en-US" sz="1100" dirty="0"/>
           </a:p>
@@ -10503,7 +10503,7 @@
                   <a:srgbClr val="1E293B"/>
                 </a:solidFill>
               </a:rPr>
-              <a:t>Gültigkeitscheck &amp; Aktionswahl</a:t>
+              <a:t>Validity Check &amp; Action Selection</a:t>
             </a:r>
             <a:endParaRPr lang="en-US" sz="1100" dirty="0"/>
           </a:p>
@@ -10600,7 +10600,7 @@
                   <a:srgbClr val="1E293B"/>
                 </a:solidFill>
               </a:rPr>
-              <a:t>Agent trainieren (5.000 Ep.)</a:t>
+              <a:t>Train Agent (5,000 Episodes)</a:t>
             </a:r>
             <a:endParaRPr lang="en-US" sz="1100" dirty="0"/>
           </a:p>
@@ -10697,7 +10697,7 @@
                   <a:srgbClr val="1E293B"/>
                 </a:solidFill>
               </a:rPr>
-              <a:t>Optimalen Pfad extrahieren</a:t>
+              <a:t>Extract Optimal Path</a:t>
             </a:r>
             <a:endParaRPr lang="en-US" sz="1100" dirty="0"/>
           </a:p>
@@ -10794,7 +10794,7 @@
                   <a:srgbClr val="1E293B"/>
                 </a:solidFill>
               </a:rPr>
-              <a:t>Labyrinth visualisieren</a:t>
+              <a:t>Visualize Maze &amp; Path</a:t>
             </a:r>
             <a:endParaRPr lang="en-US" sz="1100" dirty="0"/>
           </a:p>
@@ -10891,7 +10891,7 @@
                   <a:srgbClr val="1E293B"/>
                 </a:solidFill>
               </a:rPr>
-              <a:t>Lernkurve plotten</a:t>
+              <a:t>Plot Learning Curve</a:t>
             </a:r>
             <a:endParaRPr lang="en-US" sz="1100" dirty="0"/>
           </a:p>
@@ -10952,7 +10952,7 @@
                   <a:srgbClr val="FFFFFF"/>
                 </a:solidFill>
               </a:rPr>
-              <a:t>Folie 5 / 7</a:t>
+              <a:t>Slide 5 / 7</a:t>
             </a:r>
             <a:endParaRPr lang="en-US" sz="1000" dirty="0"/>
           </a:p>
@@ -11045,7 +11045,7 @@
                   <a:srgbClr val="FFFFFF"/>
                 </a:solidFill>
               </a:rPr>
-              <a:t>Ergebnisse &amp; Analyse</a:t>
+              <a:t>Results &amp; Analysis</a:t>
             </a:r>
             <a:endParaRPr lang="en-US" sz="2200" dirty="0"/>
           </a:p>
@@ -11154,7 +11154,7 @@
                   <a:srgbClr val="1E293B"/>
                 </a:solidFill>
               </a:rPr>
-              <a:t>✅  Agent findet den Weg</a:t>
+              <a:t>✅  Agent Finds the Path</a:t>
             </a:r>
             <a:endParaRPr lang="en-US" sz="1200" dirty="0"/>
           </a:p>
@@ -11190,7 +11190,7 @@
                   <a:srgbClr val="64748B"/>
                 </a:solidFill>
               </a:rPr>
-              <a:t>Nach 5.000 Episoden navigiert er zuverlässig vom Start zum Ziel.</a:t>
+              <a:t>After 5,000 episodes it reliably navigates from start to goal.</a:t>
             </a:r>
             <a:endParaRPr lang="en-US" sz="1000" dirty="0"/>
           </a:p>
@@ -11283,7 +11283,7 @@
                   <a:srgbClr val="1E293B"/>
                 </a:solidFill>
               </a:rPr>
-              <a:t>📈  Klare Lernkurve</a:t>
+              <a:t>📈  Clear Learning Curve</a:t>
             </a:r>
             <a:endParaRPr lang="en-US" sz="1200" dirty="0"/>
           </a:p>
@@ -11319,7 +11319,7 @@
                   <a:srgbClr val="64748B"/>
                 </a:solidFill>
               </a:rPr>
-              <a:t>Belohnungen steigen von ~-85 auf ~+44 — deutlicher Lernfortschritt.</a:t>
+              <a:t>Rewards rise from ~-85 to ~+44 — clear learning progress.</a:t>
             </a:r>
             <a:endParaRPr lang="en-US" sz="1000" dirty="0"/>
           </a:p>
@@ -11412,7 +11412,7 @@
                   <a:srgbClr val="1E293B"/>
                 </a:solidFill>
               </a:rPr>
-              <a:t>⚠️  Herausforderung</a:t>
+              <a:t>⚠️  Challenge</a:t>
             </a:r>
             <a:endParaRPr lang="en-US" sz="1200" dirty="0"/>
           </a:p>
@@ -11448,7 +11448,7 @@
                   <a:srgbClr val="64748B"/>
                 </a:solidFill>
               </a:rPr>
-              <a:t>Epsilon-Decay zu schnell → Agent bleibt in suboptimalen Pfaden stecken.</a:t>
+              <a:t>Epsilon decay too fast → agent gets stuck in suboptimal paths.</a:t>
             </a:r>
             <a:endParaRPr lang="en-US" sz="1000" dirty="0"/>
           </a:p>
@@ -11511,7 +11511,7 @@
                   <a:srgbClr val="1E293B"/>
                 </a:solidFill>
               </a:rPr>
-              <a:t>💡  Was würde ich anders machen?  Mehr Episoden + verschiedene Epsilon-Decay-Raten vergleichen.</a:t>
+              <a:t>💡  What would I do differently?  Train more episodes + compare different epsilon decay rates.</a:t>
             </a:r>
             <a:endParaRPr lang="en-US" sz="1200" dirty="0"/>
           </a:p>
@@ -11572,7 +11572,7 @@
                   <a:srgbClr val="FFFFFF"/>
                 </a:solidFill>
               </a:rPr>
-              <a:t>Folie 6 / 7</a:t>
+              <a:t>Slide 6 / 7</a:t>
             </a:r>
             <a:endParaRPr lang="en-US" sz="1000" dirty="0"/>
           </a:p>
@@ -14981,7 +14981,7 @@
                   <a:srgbClr val="FFFFFF"/>
                 </a:solidFill>
               </a:rPr>
-              <a:t>RL = Agent lernt durch Versuch &amp; Irrtum — kein gelabeltes Daten nötig</a:t>
+              <a:t>RL = Agent learns through trial &amp; error — no labeled data needed</a:t>
             </a:r>
             <a:endParaRPr lang="en-US" sz="1300" dirty="0"/>
           </a:p>
@@ -15042,7 +15042,7 @@
                   <a:srgbClr val="FFFFFF"/>
                 </a:solidFill>
               </a:rPr>
-              <a:t>Q-Learning speichert Erfahrungen in einer Tabelle und lernt den optimalen Weg</a:t>
+              <a:t>Q-Learning stores experience in a table and learns the optimal path</a:t>
             </a:r>
             <a:endParaRPr lang="en-US" sz="1300" dirty="0"/>
           </a:p>
@@ -15103,7 +15103,7 @@
                   <a:srgbClr val="FFFFFF"/>
                 </a:solidFill>
               </a:rPr>
-              <a:t>Das Exploration-Exploitation-Dilemma ist das Herzstück von RL — auch im echten Leben</a:t>
+              <a:t>The Exploration-Exploitation dilemma is the core of RL — and applies to real life too</a:t>
             </a:r>
             <a:endParaRPr lang="en-US" sz="1300" dirty="0"/>
           </a:p>
@@ -15164,7 +15164,7 @@
                   <a:srgbClr val="FFFFFF"/>
                 </a:solidFill>
               </a:rPr>
-              <a:t>Grid World ist ideal zum Verstehen: einfach, visuell, nachvollziehbar</a:t>
+              <a:t>Grid World is perfect for learning: simple, visual, intuitive</a:t>
             </a:r>
             <a:endParaRPr lang="en-US" sz="1300" dirty="0"/>
           </a:p>
@@ -15200,7 +15200,7 @@
                   <a:srgbClr val="14B8A6"/>
                 </a:solidFill>
               </a:rPr>
-              <a:t>Ressourcen:</a:t>
+              <a:t>Resources:</a:t>
             </a:r>
             <a:endParaRPr lang="en-US" sz="1200" dirty="0"/>
           </a:p>
@@ -15297,7 +15297,7 @@
                   <a:srgbClr val="FFFFFF"/>
                 </a:solidFill>
               </a:rPr>
-              <a:t>DNL  ·  Ironhack Data Science Bootcamp  ·  2026          Danke!</a:t>
+              <a:t>DNL  ·  Ironhack Data Science Bootcamp  ·  2026          Thank You!</a:t>
             </a:r>
             <a:endParaRPr lang="en-US" sz="1100" dirty="0"/>
           </a:p>

</xml_diff>

<commit_message>
Fix: translate all remaining German text to English in presentation
</commit_message>
<xml_diff>
--- a/RL_GridWorld_Presentation.pptx
+++ b/RL_GridWorld_Presentation.pptx
@@ -144,7 +144,7 @@
                 </a:solidFill>
                 <a:latin typeface="Arial"/>
               </a:rPr>
-              <a:t>Belohnung pro Episode</a:t>
+              <a:t>Reward per Episode</a:t>
             </a:r>
           </a:p>
         </c:rich>
@@ -4027,7 +4027,7 @@
                   <a:srgbClr val="FFFFFF"/>
                 </a:solidFill>
               </a:rPr>
-              <a:t>Ergebnisse &amp; Analyse</a:t>
+              <a:t>Results &amp; Analysis</a:t>
             </a:r>
             <a:endParaRPr lang="en-US" sz="2200" dirty="0"/>
           </a:p>
@@ -4136,7 +4136,7 @@
                   <a:srgbClr val="1E293B"/>
                 </a:solidFill>
               </a:rPr>
-              <a:t>✅  Agent findet den Weg</a:t>
+              <a:t>✅  Agent Finds the Path</a:t>
             </a:r>
             <a:endParaRPr lang="en-US" sz="1200" dirty="0"/>
           </a:p>
@@ -4172,7 +4172,7 @@
                   <a:srgbClr val="64748B"/>
                 </a:solidFill>
               </a:rPr>
-              <a:t>Nach 5.000 Episoden navigiert er zuverlässig vom Start zum Ziel.</a:t>
+              <a:t>After 5,000 episodes it reliably navigates from start to goal.</a:t>
             </a:r>
             <a:endParaRPr lang="en-US" sz="1000" dirty="0"/>
           </a:p>
@@ -4265,7 +4265,7 @@
                   <a:srgbClr val="1E293B"/>
                 </a:solidFill>
               </a:rPr>
-              <a:t>📈  Klare Lernkurve</a:t>
+              <a:t>📈  Clear Learning Curve</a:t>
             </a:r>
             <a:endParaRPr lang="en-US" sz="1200" dirty="0"/>
           </a:p>
@@ -4301,7 +4301,7 @@
                   <a:srgbClr val="64748B"/>
                 </a:solidFill>
               </a:rPr>
-              <a:t>Belohnungen steigen von ~-85 auf ~+44 — deutlicher Lernfortschritt.</a:t>
+              <a:t>Rewards rise from ~-85 to ~+44 — clear learning progress.</a:t>
             </a:r>
             <a:endParaRPr lang="en-US" sz="1000" dirty="0"/>
           </a:p>
@@ -4394,7 +4394,7 @@
                   <a:srgbClr val="1E293B"/>
                 </a:solidFill>
               </a:rPr>
-              <a:t>⚠️  Herausforderung</a:t>
+              <a:t>⚠️  Challenge</a:t>
             </a:r>
             <a:endParaRPr lang="en-US" sz="1200" dirty="0"/>
           </a:p>
@@ -4430,7 +4430,7 @@
                   <a:srgbClr val="64748B"/>
                 </a:solidFill>
               </a:rPr>
-              <a:t>Epsilon-Decay zu schnell → Agent bleibt in suboptimalen Pfaden stecken.</a:t>
+              <a:t>Epsilon decay too fast → agent gets stuck in suboptimal paths.</a:t>
             </a:r>
             <a:endParaRPr lang="en-US" sz="1000" dirty="0"/>
           </a:p>
@@ -4493,7 +4493,7 @@
                   <a:srgbClr val="1E293B"/>
                 </a:solidFill>
               </a:rPr>
-              <a:t>💡  Was würde ich anders machen?  Mehr Episoden + verschiedene Epsilon-Decay-Raten vergleichen.</a:t>
+              <a:t>💡  What would I do differently?  Train more episodes + compare different epsilon decay rates.</a:t>
             </a:r>
             <a:endParaRPr lang="en-US" sz="1200" dirty="0"/>
           </a:p>
@@ -7963,7 +7963,7 @@
                   <a:srgbClr val="FFFFFF"/>
                 </a:solidFill>
               </a:rPr>
-              <a:t>RL = Agent lernt durch Versuch &amp; Irrtum — kein gelabeltes Daten nötig</a:t>
+              <a:t>RL = Agent learns through trial &amp; error — no labeled data needed</a:t>
             </a:r>
             <a:endParaRPr lang="en-US" sz="1300" dirty="0"/>
           </a:p>
@@ -8024,7 +8024,7 @@
                   <a:srgbClr val="FFFFFF"/>
                 </a:solidFill>
               </a:rPr>
-              <a:t>Q-Learning speichert Erfahrungen in einer Tabelle und lernt den optimalen Weg</a:t>
+              <a:t>Q-Learning stores experience in a table and learns the optimal path</a:t>
             </a:r>
             <a:endParaRPr lang="en-US" sz="1300" dirty="0"/>
           </a:p>
@@ -8085,7 +8085,7 @@
                   <a:srgbClr val="FFFFFF"/>
                 </a:solidFill>
               </a:rPr>
-              <a:t>Das Exploration-Exploitation-Dilemma ist das Herzstück von RL — auch im echten Leben</a:t>
+              <a:t>The Exploration-Exploitation dilemma is the core of RL — and applies to real life too</a:t>
             </a:r>
             <a:endParaRPr lang="en-US" sz="1300" dirty="0"/>
           </a:p>
@@ -8146,7 +8146,7 @@
                   <a:srgbClr val="FFFFFF"/>
                 </a:solidFill>
               </a:rPr>
-              <a:t>Grid World ist ideal zum Verstehen: einfach, visuell, nachvollziehbar</a:t>
+              <a:t>Grid World is perfect for learning: simple, visual, intuitive</a:t>
             </a:r>
             <a:endParaRPr lang="en-US" sz="1300" dirty="0"/>
           </a:p>
@@ -8182,7 +8182,7 @@
                   <a:srgbClr val="14B8A6"/>
                 </a:solidFill>
               </a:rPr>
-              <a:t>Ressourcen:</a:t>
+              <a:t>Resources:</a:t>
             </a:r>
             <a:endParaRPr lang="en-US" sz="1200" dirty="0"/>
           </a:p>
@@ -8476,7 +8476,7 @@
                   <a:srgbClr val="1E293B"/>
                 </a:solidFill>
               </a:rPr>
-              <a:t>Ein Agent interagiert mit einer Umgebung.</a:t>
+              <a:t>An agent interacts with an environment.</a:t>
             </a:r>
             <a:endParaRPr lang="en-US" sz="1300" dirty="0"/>
           </a:p>
@@ -8504,7 +8504,7 @@
                   <a:srgbClr val="1E293B"/>
                 </a:solidFill>
               </a:rPr>
-              <a:t>Er probiert Aktionen aus, bekommt Belohnungen oder Strafen — und lernt mit der Zeit, immer besser zu werden.</a:t>
+              <a:t>It tries actions, receives rewards or penalties — and learns over time to get better and better.</a:t>
             </a:r>
             <a:endParaRPr lang="en-US" sz="1300" dirty="0"/>
           </a:p>
@@ -8532,7 +8532,7 @@
                   <a:srgbClr val="1E293B"/>
                 </a:solidFill>
               </a:rPr>
-              <a:t>Kein gelabeltes Daten. Kein Lehrer. Nur: ausprobieren → Feedback → verbessern.</a:t>
+              <a:t>No labeled data. No teacher. Just: try → get feedback → improve.</a:t>
             </a:r>
             <a:endParaRPr lang="en-US" sz="1300" dirty="0"/>
           </a:p>
@@ -8672,7 +8672,7 @@
                   <a:srgbClr val="64748B"/>
                 </a:solidFill>
               </a:rPr>
-              <a:t>Der Lernende — trifft Entscheidungen</a:t>
+              <a:t>The learner — makes decisions</a:t>
             </a:r>
             <a:endParaRPr lang="en-US" sz="1100" dirty="0"/>
           </a:p>
@@ -8708,7 +8708,7 @@
                   <a:srgbClr val="1E293B"/>
                 </a:solidFill>
               </a:rPr>
-              <a:t>🌍  Umgebung</a:t>
+              <a:t>🌍  Environment</a:t>
             </a:r>
             <a:endParaRPr lang="en-US" sz="1200" dirty="0"/>
           </a:p>
@@ -8744,7 +8744,7 @@
                   <a:srgbClr val="64748B"/>
                 </a:solidFill>
               </a:rPr>
-              <a:t>Das System, in dem er agiert</a:t>
+              <a:t>The system the agent operates in</a:t>
             </a:r>
             <a:endParaRPr lang="en-US" sz="1100" dirty="0"/>
           </a:p>
@@ -8780,7 +8780,7 @@
                   <a:srgbClr val="1E293B"/>
                 </a:solidFill>
               </a:rPr>
-              <a:t>📍  Zustand (State)</a:t>
+              <a:t>📍  State</a:t>
             </a:r>
             <a:endParaRPr lang="en-US" sz="1200" dirty="0"/>
           </a:p>
@@ -8816,7 +8816,7 @@
                   <a:srgbClr val="64748B"/>
                 </a:solidFill>
               </a:rPr>
-              <a:t>Wo befindet sich der Agent gerade?</a:t>
+              <a:t>Where is the agent right now?</a:t>
             </a:r>
             <a:endParaRPr lang="en-US" sz="1100" dirty="0"/>
           </a:p>
@@ -8852,7 +8852,7 @@
                   <a:srgbClr val="1E293B"/>
                 </a:solidFill>
               </a:rPr>
-              <a:t>🎮  Aktion</a:t>
+              <a:t>🎮  Action</a:t>
             </a:r>
             <a:endParaRPr lang="en-US" sz="1200" dirty="0"/>
           </a:p>
@@ -8888,7 +8888,7 @@
                   <a:srgbClr val="64748B"/>
                 </a:solidFill>
               </a:rPr>
-              <a:t>Was tut er als nächstes?</a:t>
+              <a:t>What does it do next?</a:t>
             </a:r>
             <a:endParaRPr lang="en-US" sz="1100" dirty="0"/>
           </a:p>
@@ -8924,7 +8924,7 @@
                   <a:srgbClr val="1E293B"/>
                 </a:solidFill>
               </a:rPr>
-              <a:t>🏆  Belohnung</a:t>
+              <a:t>🏆  Reward</a:t>
             </a:r>
             <a:endParaRPr lang="en-US" sz="1200" dirty="0"/>
           </a:p>
@@ -8960,7 +8960,7 @@
                   <a:srgbClr val="64748B"/>
                 </a:solidFill>
               </a:rPr>
-              <a:t>Wie gut war die Entscheidung?</a:t>
+              <a:t>How good was the decision?</a:t>
             </a:r>
             <a:endParaRPr lang="en-US" sz="1100" dirty="0"/>
           </a:p>
@@ -11686,7 +11686,7 @@
                   <a:srgbClr val="FFFFFF"/>
                 </a:solidFill>
               </a:rPr>
-              <a:t>Z</a:t>
+              <a:t>G</a:t>
             </a:r>
             <a:endParaRPr lang="en-US" sz="900" dirty="0"/>
           </a:p>
@@ -11853,7 +11853,7 @@
                   <a:srgbClr val="1E293B"/>
                 </a:solidFill>
               </a:rPr>
-              <a:t>(oben links)  →  Ziel (unten rechts)</a:t>
+              <a:t>(top left)  →  Goal (bottom right)</a:t>
             </a:r>
             <a:endParaRPr lang="en-US" sz="1200" dirty="0"/>
           </a:p>
@@ -11916,7 +11916,7 @@
                   <a:srgbClr val="0D9488"/>
                 </a:solidFill>
               </a:rPr>
-              <a:t>🧱 Hindernisse</a:t>
+              <a:t>🧱 Obstacles</a:t>
             </a:r>
             <a:endParaRPr lang="en-US" sz="1100" dirty="0"/>
           </a:p>
@@ -11952,7 +11952,7 @@
                   <a:srgbClr val="1E293B"/>
                 </a:solidFill>
               </a:rPr>
-              <a:t>Wände = verboten (Strafe: -10)</a:t>
+              <a:t>Walls = forbidden (penalty: -10)</a:t>
             </a:r>
             <a:endParaRPr lang="en-US" sz="1200" dirty="0"/>
           </a:p>
@@ -12015,7 +12015,7 @@
                   <a:srgbClr val="0D9488"/>
                 </a:solidFill>
               </a:rPr>
-              <a:t>👣 Jeden Schritt</a:t>
+              <a:t>👣 Each step</a:t>
             </a:r>
             <a:endParaRPr lang="en-US" sz="1100" dirty="0"/>
           </a:p>
@@ -12051,7 +12051,7 @@
                   <a:srgbClr val="1E293B"/>
                 </a:solidFill>
               </a:rPr>
-              <a:t>kostet -1 Punkt (kürzter Weg!)</a:t>
+              <a:t>costs -1 point (find shortest path!)</a:t>
             </a:r>
             <a:endParaRPr lang="en-US" sz="1200" dirty="0"/>
           </a:p>
@@ -12114,7 +12114,7 @@
                   <a:srgbClr val="0D9488"/>
                 </a:solidFill>
               </a:rPr>
-              <a:t>🏆 Ziel erreicht</a:t>
+              <a:t>🏆 Goal reached</a:t>
             </a:r>
             <a:endParaRPr lang="en-US" sz="1100" dirty="0"/>
           </a:p>
@@ -12150,7 +12150,7 @@
                   <a:srgbClr val="1E293B"/>
                 </a:solidFill>
               </a:rPr>
-              <a:t>+50 Punkte Belohnung</a:t>
+              <a:t>+50 points reward</a:t>
             </a:r>
             <a:endParaRPr lang="en-US" sz="1200" dirty="0"/>
           </a:p>
@@ -12213,7 +12213,7 @@
                   <a:srgbClr val="0D9488"/>
                 </a:solidFill>
               </a:rPr>
-              <a:t>🔁 5.000 Versuche</a:t>
+              <a:t>🔁 5,000 episodes</a:t>
             </a:r>
             <a:endParaRPr lang="en-US" sz="1100" dirty="0"/>
           </a:p>
@@ -12249,7 +12249,7 @@
                   <a:srgbClr val="1E293B"/>
                 </a:solidFill>
               </a:rPr>
-              <a:t>um den besten Weg zu lernen</a:t>
+              <a:t>to learn the optimal path</a:t>
             </a:r>
             <a:endParaRPr lang="en-US" sz="1200" dirty="0"/>
           </a:p>
@@ -12432,7 +12432,7 @@
                   <a:srgbClr val="1E293B"/>
                 </a:solidFill>
               </a:rPr>
-              <a:t>Gelernter Pfad</a:t>
+              <a:t>Learned Path</a:t>
             </a:r>
             <a:endParaRPr lang="en-US" sz="900" dirty="0"/>
           </a:p>
@@ -12751,7 +12751,7 @@
                   <a:srgbClr val="FFFFFF"/>
                 </a:solidFill>
               </a:rPr>
-              <a:t>Wie ein Videospiel-Neuling — zuerst random Knöpfe drücken, dann aus Fehlern lernen, irgendwann den Level im Schlaf durchspielen.</a:t>
+              <a:t>Like a video game newbie — first pressing random buttons, then learning from mistakes, eventually playing the level in your sleep.</a:t>
             </a:r>
             <a:endParaRPr lang="en-US" sz="1300" dirty="0"/>
           </a:p>
@@ -12844,7 +12844,7 @@
                   <a:srgbClr val="FFFFFF"/>
                 </a:solidFill>
               </a:rPr>
-              <a:t>1. Beobachten</a:t>
+              <a:t>1. Observe</a:t>
             </a:r>
             <a:endParaRPr lang="en-US" sz="1200" dirty="0"/>
           </a:p>
@@ -12916,7 +12916,7 @@
                   <a:srgbClr val="64748B"/>
                 </a:solidFill>
               </a:rPr>
-              <a:t>Agent sieht seinen</a:t>
+              <a:t>Agent sees its</a:t>
             </a:r>
             <a:endParaRPr lang="en-US" sz="1100" dirty="0"/>
           </a:p>
@@ -12930,7 +12930,7 @@
                   <a:srgbClr val="64748B"/>
                 </a:solidFill>
               </a:rPr>
-              <a:t>aktuellen Zustand</a:t>
+              <a:t>current state</a:t>
             </a:r>
             <a:endParaRPr lang="en-US" sz="1100" dirty="0"/>
           </a:p>
@@ -13048,7 +13048,7 @@
                   <a:srgbClr val="FFFFFF"/>
                 </a:solidFill>
               </a:rPr>
-              <a:t>2. Handeln</a:t>
+              <a:t>2. Act</a:t>
             </a:r>
             <a:endParaRPr lang="en-US" sz="1200" dirty="0"/>
           </a:p>
@@ -13120,7 +13120,7 @@
                   <a:srgbClr val="64748B"/>
                 </a:solidFill>
               </a:rPr>
-              <a:t>Wählt eine Aktion</a:t>
+              <a:t>Picks an action</a:t>
             </a:r>
             <a:endParaRPr lang="en-US" sz="1100" dirty="0"/>
           </a:p>
@@ -13324,7 +13324,7 @@
                   <a:srgbClr val="64748B"/>
                 </a:solidFill>
               </a:rPr>
-              <a:t>Erhält Belohnung</a:t>
+              <a:t>Receives reward</a:t>
             </a:r>
             <a:endParaRPr lang="en-US" sz="1100" dirty="0"/>
           </a:p>
@@ -13338,7 +13338,7 @@
                   <a:srgbClr val="64748B"/>
                 </a:solidFill>
               </a:rPr>
-              <a:t>oder Strafe</a:t>
+              <a:t>or penalty</a:t>
             </a:r>
             <a:endParaRPr lang="en-US" sz="1100" dirty="0"/>
           </a:p>
@@ -13456,7 +13456,7 @@
                   <a:srgbClr val="FFFFFF"/>
                 </a:solidFill>
               </a:rPr>
-              <a:t>4. Lernen</a:t>
+              <a:t>4. Learn</a:t>
             </a:r>
             <a:endParaRPr lang="en-US" sz="1200" dirty="0"/>
           </a:p>
@@ -13528,7 +13528,7 @@
                   <a:srgbClr val="64748B"/>
                 </a:solidFill>
               </a:rPr>
-              <a:t>Aktualisiert die</a:t>
+              <a:t>Updates the</a:t>
             </a:r>
             <a:endParaRPr lang="en-US" sz="1100" dirty="0"/>
           </a:p>
@@ -13542,7 +13542,7 @@
                   <a:srgbClr val="64748B"/>
                 </a:solidFill>
               </a:rPr>
-              <a:t>Q-Tabelle</a:t>
+              <a:t>Q-table</a:t>
             </a:r>
             <a:endParaRPr lang="en-US" sz="1100" dirty="0"/>
           </a:p>
@@ -13803,7 +13803,7 @@
                   <a:srgbClr val="FFFFFF"/>
                 </a:solidFill>
               </a:rPr>
-              <a:t>Schlüssel-Parameter &amp; ε-Greedy Strategie</a:t>
+              <a:t>Key Parameters &amp; ε-Greedy Strategy</a:t>
             </a:r>
             <a:endParaRPr lang="en-US" sz="2200" dirty="0"/>
           </a:p>
@@ -14165,7 +14165,7 @@
                   <a:srgbClr val="64748B"/>
                 </a:solidFill>
               </a:rPr>
-              <a:t>Lernrate — wie stark neue Info alte überschreibt</a:t>
+              <a:t>Learning rate — how much new info overrides old</a:t>
             </a:r>
             <a:endParaRPr lang="en-US" sz="1100" dirty="0"/>
           </a:p>
@@ -14326,7 +14326,7 @@
                   <a:srgbClr val="64748B"/>
                 </a:solidFill>
               </a:rPr>
-              <a:t>Diskontierung — zukünftige Belohnungen zählen fast gleich viel</a:t>
+              <a:t>Discount factor — future rewards count almost as much as immediate</a:t>
             </a:r>
             <a:endParaRPr lang="en-US" sz="1100" dirty="0"/>
           </a:p>
@@ -14487,7 +14487,7 @@
                   <a:srgbClr val="64748B"/>
                 </a:solidFill>
               </a:rPr>
-              <a:t>Exploration sinkt mit jeder Episode</a:t>
+              <a:t>Exploration decays each episode</a:t>
             </a:r>
             <a:endParaRPr lang="en-US" sz="1100" dirty="0"/>
           </a:p>
@@ -14648,7 +14648,7 @@
                   <a:srgbClr val="64748B"/>
                 </a:solidFill>
               </a:rPr>
-              <a:t>Anzahl der kompletten Durchläufe durchs Labyrinth</a:t>
+              <a:t>Number of complete runs through the maze</a:t>
             </a:r>
             <a:endParaRPr lang="en-US" sz="1100" dirty="0"/>
           </a:p>
@@ -14716,7 +14716,7 @@
                   <a:srgbClr val="0D9488"/>
                 </a:solidFill>
               </a:rPr>
-              <a:t>ε-Greedy Strategie</a:t>
+              <a:t>ε-Greedy Strategy</a:t>
             </a:r>
             <a:endParaRPr lang="en-US" sz="1400" dirty="0"/>
           </a:p>
@@ -14815,7 +14815,7 @@
                   <a:srgbClr val="1E293B"/>
                 </a:solidFill>
               </a:rPr>
-              <a:t>Zufällige Aktion</a:t>
+              <a:t>Random action</a:t>
             </a:r>
             <a:endParaRPr lang="en-US" sz="1000" dirty="0"/>
           </a:p>
@@ -14829,7 +14829,7 @@
                   <a:srgbClr val="1E293B"/>
                 </a:solidFill>
               </a:rPr>
-              <a:t>Agent erkundet unbekannte Felder</a:t>
+              <a:t>Agent explores unknown cells</a:t>
             </a:r>
             <a:endParaRPr lang="en-US" sz="1000" dirty="0"/>
           </a:p>
@@ -14865,7 +14865,7 @@
                   <a:srgbClr val="64748B"/>
                 </a:solidFill>
               </a:rPr>
-              <a:t>mit Wahrsch. ε    vs    (1-ε)</a:t>
+              <a:t>with prob. ε    vs    (1-ε)</a:t>
             </a:r>
             <a:endParaRPr lang="en-US" sz="1000" dirty="0"/>
           </a:p>
@@ -15132,7 +15132,7 @@
                   <a:srgbClr val="FFFFFF"/>
                 </a:solidFill>
               </a:rPr>
-              <a:t>Implementierung: Code-Überblick</a:t>
+              <a:t>Implementation: Code Overview</a:t>
             </a:r>
             <a:endParaRPr lang="en-US" sz="2200" dirty="0"/>
           </a:p>
@@ -15513,7 +15513,7 @@
                   <a:srgbClr val="0D9488"/>
                 </a:solidFill>
               </a:rPr>
-              <a:t>7 Schritte im Notebook</a:t>
+              <a:t>7 Steps in the Notebook</a:t>
             </a:r>
             <a:endParaRPr lang="en-US" sz="1300" dirty="0"/>
           </a:p>
@@ -15610,7 +15610,7 @@
                   <a:srgbClr val="1E293B"/>
                 </a:solidFill>
               </a:rPr>
-              <a:t>Libraries &amp; Labyrinth</a:t>
+              <a:t>Libraries &amp; Maze</a:t>
             </a:r>
             <a:endParaRPr lang="en-US" sz="1100" dirty="0"/>
           </a:p>
@@ -15707,7 +15707,7 @@
                   <a:srgbClr val="1E293B"/>
                 </a:solidFill>
               </a:rPr>
-              <a:t>RL Parameter &amp; Q-Tabelle</a:t>
+              <a:t>RL Parameters &amp; Q-Table</a:t>
             </a:r>
             <a:endParaRPr lang="en-US" sz="1100" dirty="0"/>
           </a:p>
@@ -15804,7 +15804,7 @@
                   <a:srgbClr val="1E293B"/>
                 </a:solidFill>
               </a:rPr>
-              <a:t>Gültigkeitscheck &amp; Aktionswahl</a:t>
+              <a:t>Validity Check &amp; Action Selection</a:t>
             </a:r>
             <a:endParaRPr lang="en-US" sz="1100" dirty="0"/>
           </a:p>
@@ -15901,7 +15901,7 @@
                   <a:srgbClr val="1E293B"/>
                 </a:solidFill>
               </a:rPr>
-              <a:t>Agent trainieren (5.000 Ep.)</a:t>
+              <a:t>Train Agent (5,000 Episodes)</a:t>
             </a:r>
             <a:endParaRPr lang="en-US" sz="1100" dirty="0"/>
           </a:p>
@@ -15998,7 +15998,7 @@
                   <a:srgbClr val="1E293B"/>
                 </a:solidFill>
               </a:rPr>
-              <a:t>Optimalen Pfad extrahieren</a:t>
+              <a:t>Extract Optimal Path</a:t>
             </a:r>
             <a:endParaRPr lang="en-US" sz="1100" dirty="0"/>
           </a:p>
@@ -16095,7 +16095,7 @@
                   <a:srgbClr val="1E293B"/>
                 </a:solidFill>
               </a:rPr>
-              <a:t>Labyrinth visualisieren</a:t>
+              <a:t>Visualize Maze &amp; Path</a:t>
             </a:r>
             <a:endParaRPr lang="en-US" sz="1100" dirty="0"/>
           </a:p>
@@ -16192,7 +16192,7 @@
                   <a:srgbClr val="1E293B"/>
                 </a:solidFill>
               </a:rPr>
-              <a:t>Lernkurve plotten</a:t>
+              <a:t>Plot Learning Curve</a:t>
             </a:r>
             <a:endParaRPr lang="en-US" sz="1100" dirty="0"/>
           </a:p>

</xml_diff>